<commit_message>
Edit TBML deck wording for plainer, more natural phrasing
Co-Authored-By: Claude Opus 5.5 <noreply@anthropic.com>
Claude-Session: https://claude.ai/code/session_01SGu78UMYPwc6tSyUvCErt9
</commit_message>
<xml_diff>
--- a/TBML_Policy_SMT_Presentation.pptx
+++ b/TBML_Policy_SMT_Presentation.pptx
@@ -118,13 +118,13 @@
   <p:extLst>
     <p:ext uri="{521415D9-36F7-43E2-AB2F-B90AF26B5E84}">
       <p14:sectionLst xmlns:p14="http://schemas.microsoft.com/office/powerpoint/2010/main">
-        <p14:section name="Opening" id="{a721778a-6036-aa84-305a-30742c0d1324}">
+        <p14:section name="Opening" id="{3975e553-6ee3-0bdf-0f56-3899777e60a4}">
           <p14:sldIdLst>
             <p14:sldId id="256"/>
             <p14:sldId id="257"/>
           </p14:sldIdLst>
         </p14:section>
-        <p14:section name="The risk" id="{a04c054d-77d5-dfef-c366-9488e753bc68}">
+        <p14:section name="The risk" id="{4e914586-0929-01d8-32af-444429540c06}">
           <p14:sldIdLst>
             <p14:sldId id="258"/>
             <p14:sldId id="259"/>
@@ -132,7 +132,7 @@
             <p14:sldId id="261"/>
           </p14:sldIdLst>
         </p14:section>
-        <p14:section name="Controls" id="{7926f376-94c8-50b6-1f00-ab54fc9ea642}">
+        <p14:section name="Controls" id="{30c549f0-dd6d-87e1-e792-f85fdf7268b5}">
           <p14:sldIdLst>
             <p14:sldId id="262"/>
             <p14:sldId id="263"/>
@@ -140,7 +140,7 @@
             <p14:sldId id="265"/>
           </p14:sldIdLst>
         </p14:section>
-        <p14:section name="Close" id="{7f2718c0-b049-45d4-5040-ab36e6f974d9}">
+        <p14:section name="Close" id="{d31eba0d-f201-6361-76a2-538ed61ec9d4}">
           <p14:sldIdLst>
             <p14:sldId id="266"/>
             <p14:sldId id="267"/>
@@ -797,7 +797,7 @@
           <a:p>
             <a:r>
               <a:rPr lang="en-US" dirty="0"/>
-              <a:t>This deck summarises the bank's new Policy Guidelines on Prevention of Trade Based Money Laundering, version 1.0, prepared by the AML &amp; CFT Division. The full document runs to 74 pages. Today we cover what the risk is, how the policy controls it, and what we need from SMT before it goes to the Board.</a:t>
+              <a:t>This deck summarises the bank's new Policy Guidelines on Prevention of Trade Based Money Laundering, version 1.0, prepared by the AML &amp; CFT Division. The full document runs to 74 pages. Today we cover the risk itself, how the policy controls it, and what we need from SMT before the policy goes to the Board.</a:t>
             </a:r>
             <a:endParaRPr lang="en-US" dirty="0"/>
           </a:p>
@@ -1061,7 +1061,7 @@
           <a:p>
             <a:r>
               <a:rPr lang="en-US" dirty="0"/>
-              <a:t>Five asks. First, endorse the policy so it can go to the Board. Second, fund the four infrastructure tools, since price checks and screening depend on them. Third, support a joint training plan with HRD for all three review levels. Fourth, take ownership of the annual enterprise-wide review and the independent control testing the policy requires. Fifth, set the tone: the policy names sales pressure as a key reason due diligence gets skipped, and only senior management can change that. Then open for questions.</a:t>
+              <a:t>There are five requests. First, endorse the policy so it can go to the Board. Second, fund the four infrastructure tools, since price checks and screening depend on them. Third, support a joint training plan with HRD for all three review levels. Fourth, take ownership of the annual enterprise-wide review and the independent control testing the policy requires. Fifth, set the tone: the policy names sales pressure as a key reason due diligence gets skipped, and only senior management can change that. After that, open the floor for questions.</a:t>
             </a:r>
             <a:endParaRPr lang="en-US" dirty="0"/>
           </a:p>
@@ -1237,7 +1237,7 @@
           <a:p>
             <a:r>
               <a:rPr lang="en-US" dirty="0"/>
-              <a:t>FATF first focused on trade based money laundering in 2006. The idea is simple: misstate what is traded so money moves with the goods. Under MLPA 2012, smuggling money out of the country, failing to repatriate dues, or overpaying a foreign party all count as money laundering. Penalties are heavy for individuals and for the bank itself, including possible loss of licence.</a:t>
+              <a:t>FATF first focused on trade based money laundering in 2006. Launderers misstate what is traded, and the money moves with the goods. Under MLPA 2012, smuggling money out of the country, failing to repatriate dues, or overpaying a foreign party all count as money laundering. Penalties are heavy for individuals and for the bank itself, including possible loss of licence.</a:t>
             </a:r>
             <a:endParaRPr lang="en-US" dirty="0"/>
           </a:p>
@@ -1589,7 +1589,7 @@
           <a:p>
             <a:r>
               <a:rPr lang="en-US" dirty="0"/>
-              <a:t>Section 2.2 sets out a risk-based approach on four layers. First the infrastructure, because no control works without tools. Second the customer, scored before they trade. Third the transaction, which is where TBML actually takes place, so it gets the three-level review. Fourth the enterprise level, where senior management reviews the whole picture each year. The four infrastructure tools at the bottom are still being set up and need budget.</a:t>
+              <a:t>Section 2.2 sets out a risk-based approach on four layers. First the infrastructure, because no control works without tools. Second the customer, scored before they trade. Third the transaction, where TBML takes place, so it gets the three-level review. Fourth the enterprise level, where senior management reviews the whole picture each year. The four infrastructure tools at the bottom are still being set up and need budget.</a:t>
             </a:r>
             <a:endParaRPr lang="en-US" dirty="0"/>
           </a:p>
@@ -1765,7 +1765,7 @@
           <a:p>
             <a:r>
               <a:rPr lang="en-US" dirty="0"/>
-              <a:t>Section 2.2.3 is the heart of the policy. Level 1 is the processing team: they check KYC and the Trade Transaction Profile, analyse alerts and screen sanctions on every deal. What they cannot clear goes to Level 2, trade AML specialists who dig deeper with third-party data. Level 3 is the DCAMLCO or a CAMLCO nominee, who makes the final call and files the STR if needed. Every decision is documented. Sanction screening is never risk-based: everything is screened.</a:t>
+              <a:t>Section 2.2.3 holds the main transaction controls. Level 1 is the processing team: they check KYC and the Trade Transaction Profile, analyse alerts and screen sanctions on every deal. What they cannot clear goes to Level 2, trade AML specialists who dig deeper with third-party data. Level 3 is the DCAMLCO or a CAMLCO nominee, who makes the final call and files the STR if needed. Every decision is documented. Sanction screening is never risk-based: everything is screened.</a:t>
             </a:r>
             <a:endParaRPr lang="en-US" dirty="0"/>
           </a:p>
@@ -3599,7 +3599,7 @@
                 <a:ea typeface="Cambria" pitchFamily="34" charset="-122"/>
                 <a:cs typeface="Cambria" pitchFamily="34" charset="-120"/>
               </a:rPr>
-              <a:t>Red flags our staff are trained to spot</a:t>
+              <a:t>Red flags staff must watch for</a:t>
             </a:r>
             <a:endParaRPr lang="en-US" sz="3200" dirty="0"/>
           </a:p>
@@ -10521,7 +10521,7 @@
                   <a:schemeClr val="accent3"/>
                 </a:solidFill>
               </a:rPr>
-              <a:t>Layer 3 is where laundering actually happens, so it carries the most weight.</a:t>
+              <a:t>Laundering takes place at the transaction layer, so most of the policy's controls sit there.</a:t>
             </a:r>
             <a:endParaRPr lang="en-US" sz="1400" dirty="0"/>
           </a:p>
@@ -13560,7 +13560,7 @@
                   <a:schemeClr val="accent3"/>
                 </a:solidFill>
               </a:rPr>
-              <a:t>No shortcuts on sanctions: </a:t>
+              <a:t>Sanction screening covers everyone: </a:t>
             </a:r>
             <a:pPr indent="0" marL="0">
               <a:buNone/>
@@ -13571,7 +13571,7 @@
                   <a:schemeClr val="tx1"/>
                 </a:solidFill>
               </a:rPr>
-              <a:t>every party, bank, vessel, port and country linked to the deal is screened, including parties added later.</a:t>
+              <a:t>we screen every party, bank, vessel, port and country in the deal, including late additions.</a:t>
             </a:r>
             <a:endParaRPr lang="en-US" sz="1500" dirty="0"/>
           </a:p>

</xml_diff>

<commit_message>
Apply Citizens Bank brand colours and logo to TBML SMT deck
Co-Authored-By: Claude Opus 5.5 <noreply@anthropic.com>
Claude-Session: https://claude.ai/code/session_01SGu78UMYPwc6tSyUvCErt9
</commit_message>
<xml_diff>
--- a/TBML_Policy_SMT_Presentation.pptx
+++ b/TBML_Policy_SMT_Presentation.pptx
@@ -118,13 +118,13 @@
   <p:extLst>
     <p:ext uri="{521415D9-36F7-43E2-AB2F-B90AF26B5E84}">
       <p14:sectionLst xmlns:p14="http://schemas.microsoft.com/office/powerpoint/2010/main">
-        <p14:section name="Opening" id="{3975e553-6ee3-0bdf-0f56-3899777e60a4}">
+        <p14:section name="Opening" id="{89db9f13-3c38-db02-8d34-2e2a26dc37b7}">
           <p14:sldIdLst>
             <p14:sldId id="256"/>
             <p14:sldId id="257"/>
           </p14:sldIdLst>
         </p14:section>
-        <p14:section name="The risk" id="{4e914586-0929-01d8-32af-444429540c06}">
+        <p14:section name="The risk" id="{996ca634-451d-7060-546c-f071f60113e5}">
           <p14:sldIdLst>
             <p14:sldId id="258"/>
             <p14:sldId id="259"/>
@@ -132,7 +132,7 @@
             <p14:sldId id="261"/>
           </p14:sldIdLst>
         </p14:section>
-        <p14:section name="Controls" id="{30c549f0-dd6d-87e1-e792-f85fdf7268b5}">
+        <p14:section name="Controls" id="{c089484e-d93f-2738-5afa-07adb6564813}">
           <p14:sldIdLst>
             <p14:sldId id="262"/>
             <p14:sldId id="263"/>
@@ -140,7 +140,7 @@
             <p14:sldId id="265"/>
           </p14:sldIdLst>
         </p14:section>
-        <p14:section name="Close" id="{d31eba0d-f201-6361-76a2-538ed61ec9d4}">
+        <p14:section name="Close" id="{f19f3e23-09fb-7982-df2f-11b22d79b9fe}">
           <p14:sldIdLst>
             <p14:sldId id="266"/>
             <p14:sldId id="267"/>
@@ -183,7 +183,7 @@
           </c:tx>
           <c:spPr>
             <a:solidFill>
-              <a:srgbClr val="1F4E79"/>
+              <a:srgbClr val="6B1820"/>
             </a:solidFill>
             <a:effectLst/>
           </c:spPr>
@@ -197,7 +197,7 @@
                 <a:pPr>
                   <a:defRPr b="0" i="0" strike="noStrike" sz="1300" u="none">
                     <a:solidFill>
-                      <a:srgbClr val="1B2433"/>
+                      <a:srgbClr val="241A1C"/>
                     </a:solidFill>
                     <a:latin typeface="+mn-lt"/>
                   </a:defRPr>
@@ -218,7 +218,7 @@
             <c:bubble3D val="0"/>
             <c:spPr>
               <a:solidFill>
-                <a:srgbClr val="1F4E79"/>
+                <a:srgbClr val="6B1820"/>
               </a:solidFill>
               <a:effectLst/>
             </c:spPr>
@@ -229,7 +229,7 @@
             <c:bubble3D val="0"/>
             <c:spPr>
               <a:solidFill>
-                <a:srgbClr val="C0392B"/>
+                <a:srgbClr val="B5561A"/>
               </a:solidFill>
               <a:effectLst/>
             </c:spPr>
@@ -275,7 +275,7 @@
               <a:pPr>
                 <a:defRPr b="0" i="0" strike="noStrike" sz="1300" u="none">
                   <a:solidFill>
-                    <a:srgbClr val="1B2433"/>
+                    <a:srgbClr val="241A1C"/>
                   </a:solidFill>
                   <a:latin typeface="+mn-lt"/>
                 </a:defRPr>
@@ -323,7 +323,7 @@
             <a:pPr>
               <a:defRPr sz="1300" b="0" i="0" u="none" strike="noStrike">
                 <a:solidFill>
-                  <a:srgbClr val="1B2433"/>
+                  <a:srgbClr val="241A1C"/>
                 </a:solidFill>
                 <a:latin typeface="+mn-lt"/>
               </a:defRPr>
@@ -1843,7 +1843,7 @@
     <p:bg>
       <p:bgPr>
         <a:solidFill>
-          <a:srgbClr val="0B2545"/>
+          <a:srgbClr val="4A0E15"/>
         </a:solidFill>
       </p:bgPr>
     </p:bg>
@@ -2046,12 +2046,36 @@
                   <a:schemeClr val="accent6"/>
                 </a:solidFill>
               </a:rPr>
-              <a:t>Citizens Bank PLC  |  TBML Prevention Policy v1.0  |  For SMT review</a:t>
+              <a:t>TBML Prevention Policy v1.0  |  For SMT review</a:t>
             </a:r>
             <a:endParaRPr lang="en-US" sz="1000" dirty="0"/>
           </a:p>
         </p:txBody>
       </p:sp>
+      <p:pic>
+        <p:nvPicPr>
+          <p:cNvPr id="4" name="Image 0" descr="/tmp/claude-0/-home-user-Code-check/4525390e-caa4-5b0d-aa3e-1c9b64fad23c/scratchpad/logo/logo-color.png">    </p:cNvPr>
+          <p:cNvPicPr>
+            <a:picLocks noChangeAspect="1"/>
+          </p:cNvPicPr>
+          <p:nvPr/>
+        </p:nvPicPr>
+        <p:blipFill>
+          <a:blip r:embed="rId1"/>
+          <a:stretch>
+            <a:fillRect/>
+          </a:stretch>
+        </p:blipFill>
+        <p:spPr>
+          <a:xfrm>
+            <a:off x="9494215" y="6272784"/>
+            <a:ext cx="1371600" cy="512064"/>
+          </a:xfrm>
+          <a:prstGeom prst="rect">
+            <a:avLst/>
+          </a:prstGeom>
+        </p:spPr>
+      </p:pic>
       <p:sp>
         <p:nvSpPr>
           <p:cNvPr id="25" name="Slide Number Placeholder 0"/>
@@ -2082,7 +2106,7 @@
             <a:lvl1pPr>
               <a:defRPr sz="1000">
                 <a:solidFill>
-                  <a:srgbClr val="8DA9C4"/>
+                  <a:srgbClr val="B89A9D"/>
                 </a:solidFill>
               </a:defRPr>
             </a:lvl1pPr>
@@ -2111,7 +2135,7 @@
     <p:bg>
       <p:bgPr>
         <a:solidFill>
-          <a:srgbClr val="0B2545"/>
+          <a:srgbClr val="4A0E15"/>
         </a:solidFill>
       </p:bgPr>
     </p:bg>
@@ -2171,6 +2195,30 @@
           </a:p>
         </p:txBody>
       </p:sp>
+      <p:pic>
+        <p:nvPicPr>
+          <p:cNvPr id="3" name="Image 0" descr="/tmp/claude-0/-home-user-Code-check/4525390e-caa4-5b0d-aa3e-1c9b64fad23c/scratchpad/logo/logo-white.png">    </p:cNvPr>
+          <p:cNvPicPr>
+            <a:picLocks noChangeAspect="1"/>
+          </p:cNvPicPr>
+          <p:nvPr/>
+        </p:nvPicPr>
+        <p:blipFill>
+          <a:blip r:embed="rId1"/>
+          <a:stretch>
+            <a:fillRect/>
+          </a:stretch>
+        </p:blipFill>
+        <p:spPr>
+          <a:xfrm>
+            <a:off x="9494215" y="6272784"/>
+            <a:ext cx="1371600" cy="512064"/>
+          </a:xfrm>
+          <a:prstGeom prst="rect">
+            <a:avLst/>
+          </a:prstGeom>
+        </p:spPr>
+      </p:pic>
       <p:sp>
         <p:nvSpPr>
           <p:cNvPr id="25" name="Slide Number Placeholder 0"/>
@@ -2201,7 +2249,7 @@
             <a:lvl1pPr>
               <a:defRPr sz="1000">
                 <a:solidFill>
-                  <a:srgbClr val="8DA9C4"/>
+                  <a:srgbClr val="B89A9D"/>
                 </a:solidFill>
               </a:defRPr>
             </a:lvl1pPr>
@@ -2271,7 +2319,7 @@
             <a:lvl1pPr>
               <a:defRPr sz="1000">
                 <a:solidFill>
-                  <a:srgbClr val="8DA9C4"/>
+                  <a:srgbClr val="B89A9D"/>
                 </a:solidFill>
               </a:defRPr>
             </a:lvl1pPr>
@@ -2566,42 +2614,30 @@
           <a:chExt cx="0" cy="0"/>
         </a:xfrm>
       </p:grpSpPr>
-      <p:sp>
-        <p:nvSpPr>
-          <p:cNvPr id="2" name="Bank name"/>
-          <p:cNvSpPr txBox="1"/>
-          <p:nvPr/>
-        </p:nvSpPr>
-        <p:spPr>
-          <a:xfrm>
-            <a:off x="548640" y="548640"/>
-            <a:ext cx="5486400" cy="365760"/>
-          </a:xfrm>
-          <a:prstGeom prst="rect">
-            <a:avLst/>
-          </a:prstGeom>
-          <a:noFill/>
-          <a:ln/>
-        </p:spPr>
-        <p:txBody>
-          <a:bodyPr wrap="square" lIns="0" tIns="0" rIns="0" bIns="0" rtlCol="0" anchor="ctr"/>
-          <a:lstStyle/>
-          <a:p>
-            <a:pPr indent="0" marL="0">
-              <a:buNone/>
-            </a:pPr>
-            <a:r>
-              <a:rPr lang="en-US" sz="1600" b="1" spc="400" kern="0" dirty="0">
-                <a:solidFill>
-                  <a:schemeClr val="accent5"/>
-                </a:solidFill>
-              </a:rPr>
-              <a:t>CITIZENS BANK PLC</a:t>
-            </a:r>
-            <a:endParaRPr lang="en-US" sz="1600" dirty="0"/>
-          </a:p>
-        </p:txBody>
-      </p:sp>
+      <p:pic>
+        <p:nvPicPr>
+          <p:cNvPr id="2" name="Bank logo" descr="/tmp/claude-0/-home-user-Code-check/4525390e-caa4-5b0d-aa3e-1c9b64fad23c/scratchpad/logo/logo-white.png">    </p:cNvPr>
+          <p:cNvPicPr>
+            <a:picLocks noChangeAspect="1"/>
+          </p:cNvPicPr>
+          <p:nvPr/>
+        </p:nvPicPr>
+        <p:blipFill>
+          <a:blip r:embed="rId1"/>
+          <a:stretch>
+            <a:fillRect/>
+          </a:stretch>
+        </p:blipFill>
+        <p:spPr>
+          <a:xfrm>
+            <a:off x="548640" y="411480"/>
+            <a:ext cx="2926080" cy="1097280"/>
+          </a:xfrm>
+          <a:prstGeom prst="rect">
+            <a:avLst/>
+          </a:prstGeom>
+        </p:spPr>
+      </p:pic>
       <p:sp>
         <p:nvSpPr>
           <p:cNvPr id="3" name="Text 0"/>
@@ -2742,12 +2778,12 @@
               <a:buNone/>
             </a:pPr>
             <a:r>
-              <a:rPr lang="en-US" sz="1400" i="1" dirty="0">
-                <a:solidFill>
-                  <a:schemeClr val="accent5"/>
-                </a:solidFill>
-              </a:rPr>
-              <a:t>Today-Tomorrow-Together</a:t>
+              <a:rPr lang="en-US" sz="1400" dirty="0">
+                <a:solidFill>
+                  <a:schemeClr val="accent6"/>
+                </a:solidFill>
+              </a:rPr>
+              <a:t>Confidential  |  For SMT review</a:t>
             </a:r>
             <a:endParaRPr lang="en-US" sz="1400" dirty="0"/>
           </a:p>
@@ -2768,11 +2804,11 @@
             <a:avLst/>
           </a:prstGeom>
           <a:solidFill>
-            <a:srgbClr val="13867C"/>
+            <a:srgbClr val="912125"/>
           </a:solidFill>
           <a:ln w="12700">
             <a:solidFill>
-              <a:srgbClr val="13867C"/>
+              <a:srgbClr val="912125"/>
             </a:solidFill>
             <a:prstDash val="solid"/>
           </a:ln>
@@ -2787,7 +2823,7 @@
           <p:nvPr/>
         </p:nvPicPr>
         <p:blipFill>
-          <a:blip r:embed="rId1"/>
+          <a:blip r:embed="rId2"/>
           <a:stretch>
             <a:fillRect/>
           </a:stretch>
@@ -2921,11 +2957,11 @@
             </a:avLst>
           </a:prstGeom>
           <a:solidFill>
-            <a:srgbClr val="13867C"/>
+            <a:srgbClr val="3F7A5A"/>
           </a:solidFill>
           <a:ln w="12700">
             <a:solidFill>
-              <a:srgbClr val="13867C"/>
+              <a:srgbClr val="3F7A5A"/>
             </a:solidFill>
             <a:prstDash val="solid"/>
           </a:ln>
@@ -3020,11 +3056,11 @@
             </a:avLst>
           </a:prstGeom>
           <a:solidFill>
-            <a:srgbClr val="5B9BA0"/>
+            <a:srgbClr val="557440"/>
           </a:solidFill>
           <a:ln w="12700">
             <a:solidFill>
-              <a:srgbClr val="5B9BA0"/>
+              <a:srgbClr val="557440"/>
             </a:solidFill>
             <a:prstDash val="solid"/>
           </a:ln>
@@ -3218,11 +3254,11 @@
             </a:avLst>
           </a:prstGeom>
           <a:solidFill>
-            <a:srgbClr val="C0392B"/>
+            <a:srgbClr val="B83A2B"/>
           </a:solidFill>
           <a:ln w="12700">
             <a:solidFill>
-              <a:srgbClr val="C0392B"/>
+              <a:srgbClr val="B83A2B"/>
             </a:solidFill>
             <a:prstDash val="solid"/>
           </a:ln>
@@ -3524,7 +3560,7 @@
             <a:lvl1pPr>
               <a:defRPr sz="1000">
                 <a:solidFill>
-                  <a:srgbClr val="8DA9C4"/>
+                  <a:srgbClr val="B89A9D"/>
                 </a:solidFill>
               </a:defRPr>
             </a:lvl1pPr>
@@ -3647,11 +3683,11 @@
             <a:avLst/>
           </a:prstGeom>
           <a:solidFill>
-            <a:srgbClr val="13867C"/>
+            <a:srgbClr val="912125"/>
           </a:solidFill>
           <a:ln w="12700">
             <a:solidFill>
-              <a:srgbClr val="13867C"/>
+              <a:srgbClr val="912125"/>
             </a:solidFill>
             <a:prstDash val="solid"/>
           </a:ln>
@@ -3817,11 +3853,11 @@
             <a:avLst/>
           </a:prstGeom>
           <a:solidFill>
-            <a:srgbClr val="13867C"/>
+            <a:srgbClr val="912125"/>
           </a:solidFill>
           <a:ln w="12700">
             <a:solidFill>
-              <a:srgbClr val="13867C"/>
+              <a:srgbClr val="912125"/>
             </a:solidFill>
             <a:prstDash val="solid"/>
           </a:ln>
@@ -3987,11 +4023,11 @@
             <a:avLst/>
           </a:prstGeom>
           <a:solidFill>
-            <a:srgbClr val="13867C"/>
+            <a:srgbClr val="912125"/>
           </a:solidFill>
           <a:ln w="12700">
             <a:solidFill>
-              <a:srgbClr val="13867C"/>
+              <a:srgbClr val="912125"/>
             </a:solidFill>
             <a:prstDash val="solid"/>
           </a:ln>
@@ -4157,11 +4193,11 @@
             <a:avLst/>
           </a:prstGeom>
           <a:solidFill>
-            <a:srgbClr val="13867C"/>
+            <a:srgbClr val="912125"/>
           </a:solidFill>
           <a:ln w="12700">
             <a:solidFill>
-              <a:srgbClr val="13867C"/>
+              <a:srgbClr val="912125"/>
             </a:solidFill>
             <a:prstDash val="solid"/>
           </a:ln>
@@ -4453,7 +4489,7 @@
             <a:lvl1pPr>
               <a:defRPr sz="1000">
                 <a:solidFill>
-                  <a:srgbClr val="8DA9C4"/>
+                  <a:srgbClr val="B89A9D"/>
                 </a:solidFill>
               </a:defRPr>
             </a:lvl1pPr>
@@ -4549,11 +4585,11 @@
             <a:avLst/>
           </a:prstGeom>
           <a:solidFill>
-            <a:srgbClr val="13867C"/>
+            <a:srgbClr val="912125"/>
           </a:solidFill>
           <a:ln w="12700">
             <a:solidFill>
-              <a:srgbClr val="13867C"/>
+              <a:srgbClr val="912125"/>
             </a:solidFill>
             <a:prstDash val="solid"/>
           </a:ln>
@@ -4670,11 +4706,11 @@
             <a:avLst/>
           </a:prstGeom>
           <a:solidFill>
-            <a:srgbClr val="13867C"/>
+            <a:srgbClr val="912125"/>
           </a:solidFill>
           <a:ln w="12700">
             <a:solidFill>
-              <a:srgbClr val="13867C"/>
+              <a:srgbClr val="912125"/>
             </a:solidFill>
             <a:prstDash val="solid"/>
           </a:ln>
@@ -4791,11 +4827,11 @@
             <a:avLst/>
           </a:prstGeom>
           <a:solidFill>
-            <a:srgbClr val="13867C"/>
+            <a:srgbClr val="912125"/>
           </a:solidFill>
           <a:ln w="12700">
             <a:solidFill>
-              <a:srgbClr val="13867C"/>
+              <a:srgbClr val="912125"/>
             </a:solidFill>
             <a:prstDash val="solid"/>
           </a:ln>
@@ -4912,11 +4948,11 @@
             <a:avLst/>
           </a:prstGeom>
           <a:solidFill>
-            <a:srgbClr val="13867C"/>
+            <a:srgbClr val="912125"/>
           </a:solidFill>
           <a:ln w="12700">
             <a:solidFill>
-              <a:srgbClr val="13867C"/>
+              <a:srgbClr val="912125"/>
             </a:solidFill>
             <a:prstDash val="solid"/>
           </a:ln>
@@ -5033,11 +5069,11 @@
             <a:avLst/>
           </a:prstGeom>
           <a:solidFill>
-            <a:srgbClr val="13867C"/>
+            <a:srgbClr val="912125"/>
           </a:solidFill>
           <a:ln w="12700">
             <a:solidFill>
-              <a:srgbClr val="13867C"/>
+              <a:srgbClr val="912125"/>
             </a:solidFill>
             <a:prstDash val="solid"/>
           </a:ln>
@@ -5205,7 +5241,7 @@
             <a:lvl1pPr>
               <a:defRPr sz="1000">
                 <a:solidFill>
-                  <a:srgbClr val="8DA9C4"/>
+                  <a:srgbClr val="B89A9D"/>
                 </a:solidFill>
               </a:defRPr>
             </a:lvl1pPr>
@@ -6335,7 +6371,7 @@
             <a:lvl1pPr>
               <a:defRPr sz="1000">
                 <a:solidFill>
-                  <a:srgbClr val="8DA9C4"/>
+                  <a:srgbClr val="B89A9D"/>
                 </a:solidFill>
               </a:defRPr>
             </a:lvl1pPr>
@@ -7361,7 +7397,7 @@
             <a:lvl1pPr>
               <a:defRPr sz="1000">
                 <a:solidFill>
-                  <a:srgbClr val="8DA9C4"/>
+                  <a:srgbClr val="B89A9D"/>
                 </a:solidFill>
               </a:defRPr>
             </a:lvl1pPr>
@@ -7484,11 +7520,11 @@
             <a:avLst/>
           </a:prstGeom>
           <a:solidFill>
-            <a:srgbClr val="13867C"/>
+            <a:srgbClr val="912125"/>
           </a:solidFill>
           <a:ln w="12700">
             <a:solidFill>
-              <a:srgbClr val="13867C"/>
+              <a:srgbClr val="912125"/>
             </a:solidFill>
             <a:prstDash val="solid"/>
           </a:ln>
@@ -7675,11 +7711,11 @@
             <a:avLst/>
           </a:prstGeom>
           <a:solidFill>
-            <a:srgbClr val="13867C"/>
+            <a:srgbClr val="912125"/>
           </a:solidFill>
           <a:ln w="12700">
             <a:solidFill>
-              <a:srgbClr val="13867C"/>
+              <a:srgbClr val="912125"/>
             </a:solidFill>
             <a:prstDash val="solid"/>
           </a:ln>
@@ -7866,11 +7902,11 @@
             <a:avLst/>
           </a:prstGeom>
           <a:solidFill>
-            <a:srgbClr val="13867C"/>
+            <a:srgbClr val="912125"/>
           </a:solidFill>
           <a:ln w="12700">
             <a:solidFill>
-              <a:srgbClr val="13867C"/>
+              <a:srgbClr val="912125"/>
             </a:solidFill>
             <a:prstDash val="solid"/>
           </a:ln>
@@ -8057,11 +8093,11 @@
             <a:avLst/>
           </a:prstGeom>
           <a:solidFill>
-            <a:srgbClr val="13867C"/>
+            <a:srgbClr val="912125"/>
           </a:solidFill>
           <a:ln w="12700">
             <a:solidFill>
-              <a:srgbClr val="13867C"/>
+              <a:srgbClr val="912125"/>
             </a:solidFill>
             <a:prstDash val="solid"/>
           </a:ln>
@@ -8236,7 +8272,7 @@
             <a:lvl1pPr>
               <a:defRPr sz="1000">
                 <a:solidFill>
-                  <a:srgbClr val="8DA9C4"/>
+                  <a:srgbClr val="B89A9D"/>
                 </a:solidFill>
               </a:defRPr>
             </a:lvl1pPr>
@@ -8359,11 +8395,11 @@
             <a:avLst/>
           </a:prstGeom>
           <a:solidFill>
-            <a:srgbClr val="C0392B"/>
+            <a:srgbClr val="B83A2B"/>
           </a:solidFill>
           <a:ln w="12700">
             <a:solidFill>
-              <a:srgbClr val="C0392B"/>
+              <a:srgbClr val="B83A2B"/>
             </a:solidFill>
             <a:prstDash val="solid"/>
           </a:ln>
@@ -8507,11 +8543,11 @@
             <a:avLst/>
           </a:prstGeom>
           <a:solidFill>
-            <a:srgbClr val="C0392B"/>
+            <a:srgbClr val="B83A2B"/>
           </a:solidFill>
           <a:ln w="12700">
             <a:solidFill>
-              <a:srgbClr val="C0392B"/>
+              <a:srgbClr val="B83A2B"/>
             </a:solidFill>
             <a:prstDash val="solid"/>
           </a:ln>
@@ -8655,11 +8691,11 @@
             <a:avLst/>
           </a:prstGeom>
           <a:solidFill>
-            <a:srgbClr val="13867C"/>
+            <a:srgbClr val="912125"/>
           </a:solidFill>
           <a:ln w="12700">
             <a:solidFill>
-              <a:srgbClr val="13867C"/>
+              <a:srgbClr val="912125"/>
             </a:solidFill>
             <a:prstDash val="solid"/>
           </a:ln>
@@ -8803,11 +8839,11 @@
             <a:avLst/>
           </a:prstGeom>
           <a:solidFill>
-            <a:srgbClr val="13867C"/>
+            <a:srgbClr val="912125"/>
           </a:solidFill>
           <a:ln w="12700">
             <a:solidFill>
-              <a:srgbClr val="13867C"/>
+              <a:srgbClr val="912125"/>
             </a:solidFill>
             <a:prstDash val="solid"/>
           </a:ln>
@@ -8951,11 +8987,11 @@
             <a:avLst/>
           </a:prstGeom>
           <a:solidFill>
-            <a:srgbClr val="13867C"/>
+            <a:srgbClr val="912125"/>
           </a:solidFill>
           <a:ln w="12700">
             <a:solidFill>
-              <a:srgbClr val="13867C"/>
+              <a:srgbClr val="912125"/>
             </a:solidFill>
             <a:prstDash val="solid"/>
           </a:ln>
@@ -9099,11 +9135,11 @@
             <a:avLst/>
           </a:prstGeom>
           <a:solidFill>
-            <a:srgbClr val="13867C"/>
+            <a:srgbClr val="912125"/>
           </a:solidFill>
           <a:ln w="12700">
             <a:solidFill>
-              <a:srgbClr val="13867C"/>
+              <a:srgbClr val="912125"/>
             </a:solidFill>
             <a:prstDash val="solid"/>
           </a:ln>
@@ -9247,11 +9283,11 @@
             <a:avLst/>
           </a:prstGeom>
           <a:solidFill>
-            <a:srgbClr val="13867C"/>
+            <a:srgbClr val="912125"/>
           </a:solidFill>
           <a:ln w="12700">
             <a:solidFill>
-              <a:srgbClr val="13867C"/>
+              <a:srgbClr val="912125"/>
             </a:solidFill>
             <a:prstDash val="solid"/>
           </a:ln>
@@ -9383,7 +9419,7 @@
             <a:lvl1pPr>
               <a:defRPr sz="1000">
                 <a:solidFill>
-                  <a:srgbClr val="8DA9C4"/>
+                  <a:srgbClr val="B89A9D"/>
                 </a:solidFill>
               </a:defRPr>
             </a:lvl1pPr>
@@ -9479,11 +9515,11 @@
             <a:avLst/>
           </a:prstGeom>
           <a:solidFill>
-            <a:srgbClr val="13867C"/>
+            <a:srgbClr val="912125"/>
           </a:solidFill>
           <a:ln w="12700">
             <a:solidFill>
-              <a:srgbClr val="13867C"/>
+              <a:srgbClr val="912125"/>
             </a:solidFill>
             <a:prstDash val="solid"/>
           </a:ln>
@@ -9715,11 +9751,11 @@
             <a:avLst/>
           </a:prstGeom>
           <a:solidFill>
-            <a:srgbClr val="1F4E79"/>
+            <a:srgbClr val="6B1820"/>
           </a:solidFill>
           <a:ln w="12700">
             <a:solidFill>
-              <a:srgbClr val="1F4E79"/>
+              <a:srgbClr val="6B1820"/>
             </a:solidFill>
             <a:prstDash val="solid"/>
           </a:ln>
@@ -10022,7 +10058,7 @@
             <a:lvl1pPr>
               <a:defRPr sz="1000">
                 <a:solidFill>
-                  <a:srgbClr val="8DA9C4"/>
+                  <a:srgbClr val="B89A9D"/>
                 </a:solidFill>
               </a:defRPr>
             </a:lvl1pPr>
@@ -10608,11 +10644,11 @@
             <a:avLst/>
           </a:prstGeom>
           <a:solidFill>
-            <a:srgbClr val="1F4E79"/>
+            <a:srgbClr val="6B1820"/>
           </a:solidFill>
           <a:ln w="12700">
             <a:solidFill>
-              <a:srgbClr val="1F4E79"/>
+              <a:srgbClr val="6B1820"/>
             </a:solidFill>
             <a:prstDash val="solid"/>
           </a:ln>
@@ -10729,11 +10765,11 @@
             <a:avLst/>
           </a:prstGeom>
           <a:solidFill>
-            <a:srgbClr val="1F4E79"/>
+            <a:srgbClr val="6B1820"/>
           </a:solidFill>
           <a:ln w="12700">
             <a:solidFill>
-              <a:srgbClr val="1F4E79"/>
+              <a:srgbClr val="6B1820"/>
             </a:solidFill>
             <a:prstDash val="solid"/>
           </a:ln>
@@ -10850,11 +10886,11 @@
             <a:avLst/>
           </a:prstGeom>
           <a:solidFill>
-            <a:srgbClr val="1F4E79"/>
+            <a:srgbClr val="6B1820"/>
           </a:solidFill>
           <a:ln w="12700">
             <a:solidFill>
-              <a:srgbClr val="1F4E79"/>
+              <a:srgbClr val="6B1820"/>
             </a:solidFill>
             <a:prstDash val="solid"/>
           </a:ln>
@@ -10971,11 +11007,11 @@
             <a:avLst/>
           </a:prstGeom>
           <a:solidFill>
-            <a:srgbClr val="1F4E79"/>
+            <a:srgbClr val="6B1820"/>
           </a:solidFill>
           <a:ln w="12700">
             <a:solidFill>
-              <a:srgbClr val="1F4E79"/>
+              <a:srgbClr val="6B1820"/>
             </a:solidFill>
             <a:prstDash val="solid"/>
           </a:ln>
@@ -11107,7 +11143,7 @@
             <a:lvl1pPr>
               <a:defRPr sz="1000">
                 <a:solidFill>
-                  <a:srgbClr val="8DA9C4"/>
+                  <a:srgbClr val="B89A9D"/>
                 </a:solidFill>
               </a:defRPr>
             </a:lvl1pPr>
@@ -11266,11 +11302,11 @@
             <a:avLst/>
           </a:prstGeom>
           <a:solidFill>
-            <a:srgbClr val="13867C"/>
+            <a:srgbClr val="912125"/>
           </a:solidFill>
           <a:ln w="12700">
             <a:solidFill>
-              <a:srgbClr val="13867C"/>
+              <a:srgbClr val="912125"/>
             </a:solidFill>
             <a:prstDash val="solid"/>
           </a:ln>
@@ -11414,11 +11450,11 @@
             <a:avLst/>
           </a:prstGeom>
           <a:solidFill>
-            <a:srgbClr val="13867C"/>
+            <a:srgbClr val="912125"/>
           </a:solidFill>
           <a:ln w="12700">
             <a:solidFill>
-              <a:srgbClr val="13867C"/>
+              <a:srgbClr val="912125"/>
             </a:solidFill>
             <a:prstDash val="solid"/>
           </a:ln>
@@ -11562,11 +11598,11 @@
             <a:avLst/>
           </a:prstGeom>
           <a:solidFill>
-            <a:srgbClr val="13867C"/>
+            <a:srgbClr val="912125"/>
           </a:solidFill>
           <a:ln w="12700">
             <a:solidFill>
-              <a:srgbClr val="13867C"/>
+              <a:srgbClr val="912125"/>
             </a:solidFill>
             <a:prstDash val="solid"/>
           </a:ln>
@@ -11710,11 +11746,11 @@
             <a:avLst/>
           </a:prstGeom>
           <a:solidFill>
-            <a:srgbClr val="13867C"/>
+            <a:srgbClr val="912125"/>
           </a:solidFill>
           <a:ln w="12700">
             <a:solidFill>
-              <a:srgbClr val="13867C"/>
+              <a:srgbClr val="912125"/>
             </a:solidFill>
             <a:prstDash val="solid"/>
           </a:ln>
@@ -11869,11 +11905,11 @@
             </a:avLst>
           </a:prstGeom>
           <a:solidFill>
-            <a:srgbClr val="C0392B"/>
+            <a:srgbClr val="B83A2B"/>
           </a:solidFill>
           <a:ln w="12700">
             <a:solidFill>
-              <a:srgbClr val="C0392B"/>
+              <a:srgbClr val="B83A2B"/>
             </a:solidFill>
             <a:prstDash val="solid"/>
           </a:ln>
@@ -12265,11 +12301,11 @@
             </a:avLst>
           </a:prstGeom>
           <a:solidFill>
-            <a:srgbClr val="13867C"/>
+            <a:srgbClr val="3F7A5A"/>
           </a:solidFill>
           <a:ln w="12700">
             <a:solidFill>
-              <a:srgbClr val="13867C"/>
+              <a:srgbClr val="3F7A5A"/>
             </a:solidFill>
             <a:prstDash val="solid"/>
           </a:ln>
@@ -12476,7 +12512,7 @@
             <a:lvl1pPr>
               <a:defRPr sz="1000">
                 <a:solidFill>
-                  <a:srgbClr val="8DA9C4"/>
+                  <a:srgbClr val="B89A9D"/>
                 </a:solidFill>
               </a:defRPr>
             </a:lvl1pPr>
@@ -13607,7 +13643,7 @@
             <a:lvl1pPr>
               <a:defRPr sz="1000">
                 <a:solidFill>
-                  <a:srgbClr val="8DA9C4"/>
+                  <a:srgbClr val="B89A9D"/>
                 </a:solidFill>
               </a:defRPr>
             </a:lvl1pPr>
@@ -13635,40 +13671,40 @@
   <a:themeElements>
     <a:clrScheme name="Citizens Bank TBML">
       <a:dk1>
-        <a:srgbClr val="1B2433"/>
+        <a:srgbClr val="241A1C"/>
       </a:dk1>
       <a:lt1>
         <a:srgbClr val="FFFFFF"/>
       </a:lt1>
       <a:dk2>
-        <a:srgbClr val="0B2545"/>
+        <a:srgbClr val="4A0E15"/>
       </a:dk2>
       <a:lt2>
-        <a:srgbClr val="EEF4F5"/>
+        <a:srgbClr val="F7F3F2"/>
       </a:lt2>
       <a:accent1>
-        <a:srgbClr val="13867C"/>
+        <a:srgbClr val="912125"/>
       </a:accent1>
       <a:accent2>
-        <a:srgbClr val="1F4E79"/>
+        <a:srgbClr val="6B1820"/>
       </a:accent2>
       <a:accent3>
-        <a:srgbClr val="C0392B"/>
+        <a:srgbClr val="B83A2B"/>
       </a:accent3>
       <a:accent4>
         <a:srgbClr val="D4911E"/>
       </a:accent4>
       <a:accent5>
-        <a:srgbClr val="5B9BA0"/>
+        <a:srgbClr val="C9A46E"/>
       </a:accent5>
       <a:accent6>
-        <a:srgbClr val="8DA9C4"/>
+        <a:srgbClr val="B89A9D"/>
       </a:accent6>
       <a:hlink>
-        <a:srgbClr val="13867C"/>
+        <a:srgbClr val="912125"/>
       </a:hlink>
       <a:folHlink>
-        <a:srgbClr val="1F4E79"/>
+        <a:srgbClr val="6B1820"/>
       </a:folHlink>
     </a:clrScheme>
     <a:fontScheme name="Citizens Bank TBML">

</xml_diff>